<commit_message>
Make proposal more professional: remove emojis and technical jargon
Replace emoji icons with numbered markers and accent dots, and rewrite
under-the-hood language (AI/pre-filter, OAuth/HTTPS, tokens, etc.) into
plain business benefits.

https://claude.ai/code/session_01U4hLQTdpnKSaHP8GYgfL4u
</commit_message>
<xml_diff>
--- a/proposal/LUMA_Business_Proposal.pptx
+++ b/proposal/LUMA_Business_Proposal.pptx
@@ -5082,7 +5082,7 @@
                 </a:solidFill>
                 <a:latin typeface="JetBrains Mono"/>
               </a:rPr>
-              <a:t>☰  Menu</a:t>
+              <a:t>‹  Menu</a:t>
             </a:r>
           </a:p>
         </p:txBody>
@@ -5300,36 +5300,45 @@
       </p:sp>
       <p:sp>
         <p:nvSpPr>
-          <p:cNvPr id="6" name="TextBox 5"/>
-          <p:cNvSpPr txBox="1"/>
-          <p:nvPr/>
-        </p:nvSpPr>
-        <p:spPr>
-          <a:xfrm>
-            <a:off x="1051560" y="2880360"/>
-            <a:ext cx="914400" cy="731520"/>
-          </a:xfrm>
-          <a:prstGeom prst="rect">
-            <a:avLst/>
-          </a:prstGeom>
-          <a:noFill/>
-        </p:spPr>
-        <p:txBody>
-          <a:bodyPr wrap="square" anchor="t" lIns="0" rIns="0" tIns="0" bIns="0">
-            <a:spAutoFit/>
-          </a:bodyPr>
-          <a:lstStyle/>
-          <a:p>
-            <a:pPr algn="l"/>
-            <a:r>
-              <a:rPr sz="3200" b="0" i="0">
-                <a:solidFill>
-                  <a:srgbClr val="7AA8FF"/>
-                </a:solidFill>
-                <a:latin typeface="Open Sans"/>
-              </a:rPr>
-              <a:t>🔐</a:t>
-            </a:r>
+          <p:cNvPr id="6" name="Oval 5"/>
+          <p:cNvSpPr/>
+          <p:nvPr/>
+        </p:nvSpPr>
+        <p:spPr>
+          <a:xfrm>
+            <a:off x="1097280" y="2990088"/>
+            <a:ext cx="182880" cy="182880"/>
+          </a:xfrm>
+          <a:prstGeom prst="ellipse">
+            <a:avLst/>
+          </a:prstGeom>
+          <a:solidFill>
+            <a:srgbClr val="7AA8FF"/>
+          </a:solidFill>
+          <a:ln>
+            <a:noFill/>
+          </a:ln>
+          <a:effectLst/>
+        </p:spPr>
+        <p:style>
+          <a:lnRef idx="1">
+            <a:schemeClr val="accent1"/>
+          </a:lnRef>
+          <a:fillRef idx="3">
+            <a:schemeClr val="accent1"/>
+          </a:fillRef>
+          <a:effectRef idx="2">
+            <a:schemeClr val="accent1"/>
+          </a:effectRef>
+          <a:fontRef idx="minor">
+            <a:schemeClr val="lt1"/>
+          </a:fontRef>
+        </p:style>
+        <p:txBody>
+          <a:bodyPr rtlCol="0" anchor="ctr"/>
+          <a:lstStyle/>
+          <a:p>
+            <a:pPr algn="ctr"/>
           </a:p>
         </p:txBody>
       </p:sp>
@@ -5341,8 +5350,8 @@
         </p:nvSpPr>
         <p:spPr>
           <a:xfrm>
-            <a:off x="2011680" y="2898648"/>
-            <a:ext cx="3794760" cy="1188720"/>
+            <a:off x="1645920" y="2898648"/>
+            <a:ext cx="4160520" cy="1188720"/>
           </a:xfrm>
           <a:prstGeom prst="rect">
             <a:avLst/>
@@ -5370,7 +5379,7 @@
                 </a:solidFill>
                 <a:latin typeface="Sora"/>
               </a:rPr>
-              <a:t>Per-tenant isolation</a:t>
+              <a:t>Your data stays yours</a:t>
             </a:r>
           </a:p>
           <a:p>
@@ -5389,7 +5398,7 @@
                 </a:solidFill>
                 <a:latin typeface="Open Sans"/>
               </a:rPr>
-              <a:t>Every store’s data is fully separated — never shared or co-mingled.</a:t>
+              <a:t>Every store’s information is kept completely separate and private.</a:t>
             </a:r>
           </a:p>
         </p:txBody>
@@ -5448,36 +5457,45 @@
       </p:sp>
       <p:sp>
         <p:nvSpPr>
-          <p:cNvPr id="9" name="TextBox 8"/>
-          <p:cNvSpPr txBox="1"/>
-          <p:nvPr/>
-        </p:nvSpPr>
-        <p:spPr>
-          <a:xfrm>
-            <a:off x="6675120" y="2880360"/>
-            <a:ext cx="914400" cy="731520"/>
-          </a:xfrm>
-          <a:prstGeom prst="rect">
-            <a:avLst/>
-          </a:prstGeom>
-          <a:noFill/>
-        </p:spPr>
-        <p:txBody>
-          <a:bodyPr wrap="square" anchor="t" lIns="0" rIns="0" tIns="0" bIns="0">
-            <a:spAutoFit/>
-          </a:bodyPr>
-          <a:lstStyle/>
-          <a:p>
-            <a:pPr algn="l"/>
-            <a:r>
-              <a:rPr sz="3200" b="0" i="0">
-                <a:solidFill>
-                  <a:srgbClr val="7AA8FF"/>
-                </a:solidFill>
-                <a:latin typeface="Open Sans"/>
-              </a:rPr>
-              <a:t>🔒</a:t>
-            </a:r>
+          <p:cNvPr id="9" name="Oval 8"/>
+          <p:cNvSpPr/>
+          <p:nvPr/>
+        </p:nvSpPr>
+        <p:spPr>
+          <a:xfrm>
+            <a:off x="6720840" y="2990088"/>
+            <a:ext cx="182880" cy="182880"/>
+          </a:xfrm>
+          <a:prstGeom prst="ellipse">
+            <a:avLst/>
+          </a:prstGeom>
+          <a:solidFill>
+            <a:srgbClr val="7AA8FF"/>
+          </a:solidFill>
+          <a:ln>
+            <a:noFill/>
+          </a:ln>
+          <a:effectLst/>
+        </p:spPr>
+        <p:style>
+          <a:lnRef idx="1">
+            <a:schemeClr val="accent1"/>
+          </a:lnRef>
+          <a:fillRef idx="3">
+            <a:schemeClr val="accent1"/>
+          </a:fillRef>
+          <a:effectRef idx="2">
+            <a:schemeClr val="accent1"/>
+          </a:effectRef>
+          <a:fontRef idx="minor">
+            <a:schemeClr val="lt1"/>
+          </a:fontRef>
+        </p:style>
+        <p:txBody>
+          <a:bodyPr rtlCol="0" anchor="ctr"/>
+          <a:lstStyle/>
+          <a:p>
+            <a:pPr algn="ctr"/>
           </a:p>
         </p:txBody>
       </p:sp>
@@ -5489,8 +5507,8 @@
         </p:nvSpPr>
         <p:spPr>
           <a:xfrm>
-            <a:off x="7635240" y="2898648"/>
-            <a:ext cx="3794760" cy="1188720"/>
+            <a:off x="7269480" y="2898648"/>
+            <a:ext cx="4160520" cy="1188720"/>
           </a:xfrm>
           <a:prstGeom prst="rect">
             <a:avLst/>
@@ -5518,7 +5536,7 @@
                 </a:solidFill>
                 <a:latin typeface="Sora"/>
               </a:rPr>
-              <a:t>HTTPS-only &amp; OAuth-scoped</a:t>
+              <a:t>Safe and secure</a:t>
             </a:r>
           </a:p>
           <a:p>
@@ -5537,7 +5555,7 @@
                 </a:solidFill>
                 <a:latin typeface="Open Sans"/>
               </a:rPr>
-              <a:t>Encrypted in transit; access limited to exactly what’s authorised.</a:t>
+              <a:t>Conversations are protected and access is tightly controlled.</a:t>
             </a:r>
           </a:p>
         </p:txBody>
@@ -5596,36 +5614,45 @@
       </p:sp>
       <p:sp>
         <p:nvSpPr>
-          <p:cNvPr id="12" name="TextBox 11"/>
-          <p:cNvSpPr txBox="1"/>
-          <p:nvPr/>
-        </p:nvSpPr>
-        <p:spPr>
-          <a:xfrm>
-            <a:off x="1051560" y="4846320"/>
-            <a:ext cx="914400" cy="731520"/>
-          </a:xfrm>
-          <a:prstGeom prst="rect">
-            <a:avLst/>
-          </a:prstGeom>
-          <a:noFill/>
-        </p:spPr>
-        <p:txBody>
-          <a:bodyPr wrap="square" anchor="t" lIns="0" rIns="0" tIns="0" bIns="0">
-            <a:spAutoFit/>
-          </a:bodyPr>
-          <a:lstStyle/>
-          <a:p>
-            <a:pPr algn="l"/>
-            <a:r>
-              <a:rPr sz="3200" b="0" i="0">
-                <a:solidFill>
-                  <a:srgbClr val="7AA8FF"/>
-                </a:solidFill>
-                <a:latin typeface="Open Sans"/>
-              </a:rPr>
-              <a:t>💳</a:t>
-            </a:r>
+          <p:cNvPr id="12" name="Oval 11"/>
+          <p:cNvSpPr/>
+          <p:nvPr/>
+        </p:nvSpPr>
+        <p:spPr>
+          <a:xfrm>
+            <a:off x="1097280" y="4956048"/>
+            <a:ext cx="182880" cy="182880"/>
+          </a:xfrm>
+          <a:prstGeom prst="ellipse">
+            <a:avLst/>
+          </a:prstGeom>
+          <a:solidFill>
+            <a:srgbClr val="7AA8FF"/>
+          </a:solidFill>
+          <a:ln>
+            <a:noFill/>
+          </a:ln>
+          <a:effectLst/>
+        </p:spPr>
+        <p:style>
+          <a:lnRef idx="1">
+            <a:schemeClr val="accent1"/>
+          </a:lnRef>
+          <a:fillRef idx="3">
+            <a:schemeClr val="accent1"/>
+          </a:fillRef>
+          <a:effectRef idx="2">
+            <a:schemeClr val="accent1"/>
+          </a:effectRef>
+          <a:fontRef idx="minor">
+            <a:schemeClr val="lt1"/>
+          </a:fontRef>
+        </p:style>
+        <p:txBody>
+          <a:bodyPr rtlCol="0" anchor="ctr"/>
+          <a:lstStyle/>
+          <a:p>
+            <a:pPr algn="ctr"/>
           </a:p>
         </p:txBody>
       </p:sp>
@@ -5637,8 +5664,8 @@
         </p:nvSpPr>
         <p:spPr>
           <a:xfrm>
-            <a:off x="2011680" y="4864608"/>
-            <a:ext cx="3794760" cy="1188720"/>
+            <a:off x="1645920" y="4864608"/>
+            <a:ext cx="4160520" cy="1188720"/>
           </a:xfrm>
           <a:prstGeom prst="rect">
             <a:avLst/>
@@ -5666,7 +5693,7 @@
                 </a:solidFill>
                 <a:latin typeface="Sora"/>
               </a:rPr>
-              <a:t>Card data never touches LUMA</a:t>
+              <a:t>Payments stay with your store</a:t>
             </a:r>
           </a:p>
           <a:p>
@@ -5685,7 +5712,7 @@
                 </a:solidFill>
                 <a:latin typeface="Open Sans"/>
               </a:rPr>
-              <a:t>All billing runs through Shopify’s native, PCI-compliant system.</a:t>
+              <a:t>Billing runs through your store’s trusted, secure checkout.</a:t>
             </a:r>
           </a:p>
         </p:txBody>
@@ -5744,36 +5771,45 @@
       </p:sp>
       <p:sp>
         <p:nvSpPr>
-          <p:cNvPr id="15" name="TextBox 14"/>
-          <p:cNvSpPr txBox="1"/>
-          <p:nvPr/>
-        </p:nvSpPr>
-        <p:spPr>
-          <a:xfrm>
-            <a:off x="6675120" y="4846320"/>
-            <a:ext cx="914400" cy="731520"/>
-          </a:xfrm>
-          <a:prstGeom prst="rect">
-            <a:avLst/>
-          </a:prstGeom>
-          <a:noFill/>
-        </p:spPr>
-        <p:txBody>
-          <a:bodyPr wrap="square" anchor="t" lIns="0" rIns="0" tIns="0" bIns="0">
-            <a:spAutoFit/>
-          </a:bodyPr>
-          <a:lstStyle/>
-          <a:p>
-            <a:pPr algn="l"/>
-            <a:r>
-              <a:rPr sz="3200" b="0" i="0">
-                <a:solidFill>
-                  <a:srgbClr val="7AA8FF"/>
-                </a:solidFill>
-                <a:latin typeface="Open Sans"/>
-              </a:rPr>
-              <a:t>📜</a:t>
-            </a:r>
+          <p:cNvPr id="15" name="Oval 14"/>
+          <p:cNvSpPr/>
+          <p:nvPr/>
+        </p:nvSpPr>
+        <p:spPr>
+          <a:xfrm>
+            <a:off x="6720840" y="4956048"/>
+            <a:ext cx="182880" cy="182880"/>
+          </a:xfrm>
+          <a:prstGeom prst="ellipse">
+            <a:avLst/>
+          </a:prstGeom>
+          <a:solidFill>
+            <a:srgbClr val="7AA8FF"/>
+          </a:solidFill>
+          <a:ln>
+            <a:noFill/>
+          </a:ln>
+          <a:effectLst/>
+        </p:spPr>
+        <p:style>
+          <a:lnRef idx="1">
+            <a:schemeClr val="accent1"/>
+          </a:lnRef>
+          <a:fillRef idx="3">
+            <a:schemeClr val="accent1"/>
+          </a:fillRef>
+          <a:effectRef idx="2">
+            <a:schemeClr val="accent1"/>
+          </a:effectRef>
+          <a:fontRef idx="minor">
+            <a:schemeClr val="lt1"/>
+          </a:fontRef>
+        </p:style>
+        <p:txBody>
+          <a:bodyPr rtlCol="0" anchor="ctr"/>
+          <a:lstStyle/>
+          <a:p>
+            <a:pPr algn="ctr"/>
           </a:p>
         </p:txBody>
       </p:sp>
@@ -5785,8 +5821,8 @@
         </p:nvSpPr>
         <p:spPr>
           <a:xfrm>
-            <a:off x="7635240" y="4864608"/>
-            <a:ext cx="3794760" cy="1188720"/>
+            <a:off x="7269480" y="4864608"/>
+            <a:ext cx="4160520" cy="1188720"/>
           </a:xfrm>
           <a:prstGeom prst="rect">
             <a:avLst/>
@@ -5814,7 +5850,7 @@
                 </a:solidFill>
                 <a:latin typeface="Sora"/>
               </a:rPr>
-              <a:t>GDPR webhooks honored</a:t>
+              <a:t>Privacy respected</a:t>
             </a:r>
           </a:p>
           <a:p>
@@ -5833,7 +5869,7 @@
                 </a:solidFill>
                 <a:latin typeface="Open Sans"/>
               </a:rPr>
-              <a:t>Shopify data-deletion &amp; access requests respected automatically.</a:t>
+              <a:t>Customer data-removal requests are handled automatically.</a:t>
             </a:r>
           </a:p>
         </p:txBody>
@@ -5892,7 +5928,7 @@
                 </a:solidFill>
                 <a:latin typeface="JetBrains Mono"/>
               </a:rPr>
-              <a:t>☰  Menu</a:t>
+              <a:t>‹  Menu</a:t>
             </a:r>
           </a:p>
         </p:txBody>
@@ -6266,7 +6302,7 @@
                 </a:solidFill>
                 <a:latin typeface="JetBrains Mono"/>
               </a:rPr>
-              <a:t>Private beta · limited onboarding · powered by Claude</a:t>
+              <a:t>Now welcoming a limited number of local businesses</a:t>
             </a:r>
           </a:p>
         </p:txBody>
@@ -6325,7 +6361,7 @@
                 </a:solidFill>
                 <a:latin typeface="JetBrains Mono"/>
               </a:rPr>
-              <a:t>☰  Back to menu</a:t>
+              <a:t>Back to menu</a:t>
             </a:r>
           </a:p>
         </p:txBody>
@@ -8176,8 +8212,8 @@
         </p:nvSpPr>
         <p:spPr>
           <a:xfrm>
-            <a:off x="1005840" y="2898648"/>
-            <a:ext cx="914400" cy="640080"/>
+            <a:off x="1024128" y="2898648"/>
+            <a:ext cx="1005840" cy="640080"/>
           </a:xfrm>
           <a:prstGeom prst="rect">
             <a:avLst/>
@@ -8192,13 +8228,13 @@
           <a:p>
             <a:pPr algn="l"/>
             <a:r>
-              <a:rPr sz="3000" b="0" i="0">
+              <a:rPr sz="3000" b="1" i="0">
                 <a:solidFill>
                   <a:srgbClr val="7AA8FF"/>
                 </a:solidFill>
-                <a:latin typeface="Open Sans"/>
-              </a:rPr>
-              <a:t>⏱</a:t>
+                <a:latin typeface="JetBrains Mono"/>
+              </a:rPr>
+              <a:t>01</a:t>
             </a:r>
           </a:p>
         </p:txBody>
@@ -8211,8 +8247,8 @@
         </p:nvSpPr>
         <p:spPr>
           <a:xfrm>
-            <a:off x="1005840" y="3410712"/>
-            <a:ext cx="4800600" cy="914400"/>
+            <a:off x="1920240" y="2953512"/>
+            <a:ext cx="3886200" cy="1097280"/>
           </a:xfrm>
           <a:prstGeom prst="rect">
             <a:avLst/>
@@ -8324,8 +8360,8 @@
         </p:nvSpPr>
         <p:spPr>
           <a:xfrm>
-            <a:off x="6629400" y="2898648"/>
-            <a:ext cx="914400" cy="640080"/>
+            <a:off x="6647688" y="2898648"/>
+            <a:ext cx="1005840" cy="640080"/>
           </a:xfrm>
           <a:prstGeom prst="rect">
             <a:avLst/>
@@ -8340,13 +8376,13 @@
           <a:p>
             <a:pPr algn="l"/>
             <a:r>
-              <a:rPr sz="3000" b="0" i="0">
+              <a:rPr sz="3000" b="1" i="0">
                 <a:solidFill>
                   <a:srgbClr val="7AA8FF"/>
                 </a:solidFill>
-                <a:latin typeface="Open Sans"/>
-              </a:rPr>
-              <a:t>💬</a:t>
+                <a:latin typeface="JetBrains Mono"/>
+              </a:rPr>
+              <a:t>02</a:t>
             </a:r>
           </a:p>
         </p:txBody>
@@ -8359,8 +8395,8 @@
         </p:nvSpPr>
         <p:spPr>
           <a:xfrm>
-            <a:off x="6629400" y="3410712"/>
-            <a:ext cx="4800600" cy="914400"/>
+            <a:off x="7543800" y="2953512"/>
+            <a:ext cx="3886200" cy="1097280"/>
           </a:xfrm>
           <a:prstGeom prst="rect">
             <a:avLst/>
@@ -8407,7 +8443,7 @@
                 </a:solidFill>
                 <a:latin typeface="Open Sans"/>
               </a:rPr>
-              <a:t>“Is this in stock?” “Where’s my order?” “Do you ship to me?” — answered manually, all day.</a:t>
+              <a:t>“Is this in stock?” “Where’s my order?” “Do you ship to me?” — answered by hand, all day long.</a:t>
             </a:r>
           </a:p>
         </p:txBody>
@@ -8472,8 +8508,8 @@
         </p:nvSpPr>
         <p:spPr>
           <a:xfrm>
-            <a:off x="1005840" y="4800600"/>
-            <a:ext cx="914400" cy="640080"/>
+            <a:off x="1024128" y="4800600"/>
+            <a:ext cx="1005840" cy="640080"/>
           </a:xfrm>
           <a:prstGeom prst="rect">
             <a:avLst/>
@@ -8488,13 +8524,13 @@
           <a:p>
             <a:pPr algn="l"/>
             <a:r>
-              <a:rPr sz="3000" b="0" i="0">
+              <a:rPr sz="3000" b="1" i="0">
                 <a:solidFill>
                   <a:srgbClr val="7AA8FF"/>
                 </a:solidFill>
-                <a:latin typeface="Open Sans"/>
-              </a:rPr>
-              <a:t>🌐</a:t>
+                <a:latin typeface="JetBrains Mono"/>
+              </a:rPr>
+              <a:t>03</a:t>
             </a:r>
           </a:p>
         </p:txBody>
@@ -8507,8 +8543,8 @@
         </p:nvSpPr>
         <p:spPr>
           <a:xfrm>
-            <a:off x="1005840" y="5312664"/>
-            <a:ext cx="4800600" cy="914400"/>
+            <a:off x="1920240" y="4855464"/>
+            <a:ext cx="3886200" cy="1097280"/>
           </a:xfrm>
           <a:prstGeom prst="rect">
             <a:avLst/>
@@ -8536,7 +8572,7 @@
                 </a:solidFill>
                 <a:latin typeface="Sora"/>
               </a:rPr>
-              <a:t>Customers write in 3 languages</a:t>
+              <a:t>Customers write in three languages</a:t>
             </a:r>
           </a:p>
           <a:p>
@@ -8555,7 +8591,7 @@
                 </a:solidFill>
                 <a:latin typeface="Open Sans"/>
               </a:rPr>
-              <a:t>Arabic, English, Franco-Arabic in the same inbox. Staff juggle tone and translation.</a:t>
+              <a:t>Arabic, English and Franco-Arabic in the same inbox. Your team juggles tone and translation.</a:t>
             </a:r>
           </a:p>
         </p:txBody>
@@ -8620,8 +8656,8 @@
         </p:nvSpPr>
         <p:spPr>
           <a:xfrm>
-            <a:off x="6629400" y="4800600"/>
-            <a:ext cx="914400" cy="640080"/>
+            <a:off x="6647688" y="4800600"/>
+            <a:ext cx="1005840" cy="640080"/>
           </a:xfrm>
           <a:prstGeom prst="rect">
             <a:avLst/>
@@ -8636,13 +8672,13 @@
           <a:p>
             <a:pPr algn="l"/>
             <a:r>
-              <a:rPr sz="3000" b="0" i="0">
+              <a:rPr sz="3000" b="1" i="0">
                 <a:solidFill>
                   <a:srgbClr val="7AA8FF"/>
                 </a:solidFill>
-                <a:latin typeface="Open Sans"/>
-              </a:rPr>
-              <a:t>📉</a:t>
+                <a:latin typeface="JetBrains Mono"/>
+              </a:rPr>
+              <a:t>04</a:t>
             </a:r>
           </a:p>
         </p:txBody>
@@ -8655,8 +8691,8 @@
         </p:nvSpPr>
         <p:spPr>
           <a:xfrm>
-            <a:off x="6629400" y="5312664"/>
-            <a:ext cx="4800600" cy="914400"/>
+            <a:off x="7543800" y="4855464"/>
+            <a:ext cx="3886200" cy="1097280"/>
           </a:xfrm>
           <a:prstGeom prst="rect">
             <a:avLst/>
@@ -8703,7 +8739,7 @@
                 </a:solidFill>
                 <a:latin typeface="Open Sans"/>
               </a:rPr>
-              <a:t>No idea how many messages convert, what gets asked most, or when your peak hours hit.</a:t>
+              <a:t>No idea how many messages turn into sales, what gets asked most, or when your busiest hours are.</a:t>
             </a:r>
           </a:p>
         </p:txBody>
@@ -8762,7 +8798,7 @@
                 </a:solidFill>
                 <a:latin typeface="JetBrains Mono"/>
               </a:rPr>
-              <a:t>☰  Menu</a:t>
+              <a:t>‹  Menu</a:t>
             </a:r>
           </a:p>
         </p:txBody>
@@ -8966,7 +9002,7 @@
                 </a:solidFill>
                 <a:latin typeface="Open Sans"/>
               </a:rPr>
-              <a:t>LUMA reads every Instagram DM and Shopify chat, answers in the customer’s own language with live catalog and order data, and hands off to your team only when it truly matters.</a:t>
+              <a:t>LUMA reads every Instagram message and website chat, answers in the customer’s own language using your live product and order information, and passes the conversation to your team whenever a personal touch is needed.</a:t>
             </a:r>
           </a:p>
         </p:txBody>
@@ -9045,7 +9081,7 @@
                 </a:solidFill>
                 <a:latin typeface="Open Sans"/>
               </a:rPr>
-              <a:t>Replies in under 2 seconds, 24/7</a:t>
+              <a:t>Replies instantly, day and night</a:t>
             </a:r>
           </a:p>
         </p:txBody>
@@ -9124,7 +9160,7 @@
                 </a:solidFill>
                 <a:latin typeface="Open Sans"/>
               </a:rPr>
-              <a:t>Speaks Egyptian Arabic, English &amp; Franco-Arabic natively</a:t>
+              <a:t>Speaks Egyptian Arabic, English and Franco-Arabic</a:t>
             </a:r>
           </a:p>
         </p:txBody>
@@ -9203,7 +9239,7 @@
                 </a:solidFill>
                 <a:latin typeface="Open Sans"/>
               </a:rPr>
-              <a:t>Pulls real Shopify orders &amp; catalog — no guessing</a:t>
+              <a:t>Answers order and product questions accurately</a:t>
             </a:r>
           </a:p>
         </p:txBody>
@@ -9282,7 +9318,7 @@
                 </a:solidFill>
                 <a:latin typeface="Open Sans"/>
               </a:rPr>
-              <a:t>Lives inside your Shopify Admin — not another app to learn</a:t>
+              <a:t>Works inside your store — no new app to learn</a:t>
             </a:r>
           </a:p>
         </p:txBody>
@@ -9426,8 +9462,8 @@
         </p:nvSpPr>
         <p:spPr>
           <a:xfrm>
-            <a:off x="8595360" y="1298448"/>
-            <a:ext cx="2743200" cy="457200"/>
+            <a:off x="8595360" y="1280160"/>
+            <a:ext cx="2743200" cy="365760"/>
           </a:xfrm>
           <a:prstGeom prst="rect">
             <a:avLst/>
@@ -9440,11 +9476,7 @@
           </a:bodyPr>
           <a:lstStyle/>
           <a:p>
-            <a:pPr algn="l">
-              <a:spcAft>
-                <a:spcPts val="0"/>
-              </a:spcAft>
-            </a:pPr>
+            <a:pPr algn="l"/>
             <a:r>
               <a:rPr sz="1300" b="1" i="0">
                 <a:solidFill>
@@ -9455,12 +9487,75 @@
               <a:t>LUMA</a:t>
             </a:r>
           </a:p>
-          <a:p>
-            <a:pPr algn="l">
-              <a:spcAft>
-                <a:spcPts val="0"/>
-              </a:spcAft>
-            </a:pPr>
+        </p:txBody>
+      </p:sp>
+      <p:sp>
+        <p:nvSpPr>
+          <p:cNvPr id="17" name="Oval 16"/>
+          <p:cNvSpPr/>
+          <p:nvPr/>
+        </p:nvSpPr>
+        <p:spPr>
+          <a:xfrm>
+            <a:off x="8604504" y="1636776"/>
+            <a:ext cx="77724" cy="77724"/>
+          </a:xfrm>
+          <a:prstGeom prst="ellipse">
+            <a:avLst/>
+          </a:prstGeom>
+          <a:solidFill>
+            <a:srgbClr val="22C55E"/>
+          </a:solidFill>
+          <a:ln>
+            <a:noFill/>
+          </a:ln>
+          <a:effectLst/>
+        </p:spPr>
+        <p:style>
+          <a:lnRef idx="1">
+            <a:schemeClr val="accent1"/>
+          </a:lnRef>
+          <a:fillRef idx="3">
+            <a:schemeClr val="accent1"/>
+          </a:fillRef>
+          <a:effectRef idx="2">
+            <a:schemeClr val="accent1"/>
+          </a:effectRef>
+          <a:fontRef idx="minor">
+            <a:schemeClr val="lt1"/>
+          </a:fontRef>
+        </p:style>
+        <p:txBody>
+          <a:bodyPr rtlCol="0" anchor="ctr"/>
+          <a:lstStyle/>
+          <a:p>
+            <a:pPr algn="ctr"/>
+          </a:p>
+        </p:txBody>
+      </p:sp>
+      <p:sp>
+        <p:nvSpPr>
+          <p:cNvPr id="18" name="TextBox 17"/>
+          <p:cNvSpPr txBox="1"/>
+          <p:nvPr/>
+        </p:nvSpPr>
+        <p:spPr>
+          <a:xfrm>
+            <a:off x="8750808" y="1563624"/>
+            <a:ext cx="1828800" cy="274320"/>
+          </a:xfrm>
+          <a:prstGeom prst="rect">
+            <a:avLst/>
+          </a:prstGeom>
+          <a:noFill/>
+        </p:spPr>
+        <p:txBody>
+          <a:bodyPr wrap="square" anchor="t" lIns="0" rIns="0" tIns="0" bIns="0">
+            <a:spAutoFit/>
+          </a:bodyPr>
+          <a:lstStyle/>
+          <a:p>
+            <a:pPr algn="l"/>
             <a:r>
               <a:rPr sz="900" b="0" i="0">
                 <a:solidFill>
@@ -9468,14 +9563,14 @@
                 </a:solidFill>
                 <a:latin typeface="JetBrains Mono"/>
               </a:rPr>
-              <a:t>● online</a:t>
-            </a:r>
-          </a:p>
-        </p:txBody>
-      </p:sp>
-      <p:sp>
-        <p:nvSpPr>
-          <p:cNvPr id="17" name="Rounded Rectangle 16"/>
+              <a:t>Online now</a:t>
+            </a:r>
+          </a:p>
+        </p:txBody>
+      </p:sp>
+      <p:sp>
+        <p:nvSpPr>
+          <p:cNvPr id="19" name="Rounded Rectangle 18"/>
           <p:cNvSpPr/>
           <p:nvPr/>
         </p:nvSpPr>
@@ -9532,7 +9627,7 @@
       </p:sp>
       <p:sp>
         <p:nvSpPr>
-          <p:cNvPr id="18" name="Rounded Rectangle 17"/>
+          <p:cNvPr id="20" name="Rounded Rectangle 19"/>
           <p:cNvSpPr/>
           <p:nvPr/>
         </p:nvSpPr>
@@ -9580,14 +9675,14 @@
                 </a:solidFill>
                 <a:latin typeface="Open Sans"/>
               </a:rPr>
-              <a:t>Yes! The black jacket is in stock in size M — EGP 1,250. Want me to reserve one? 🧥</a:t>
-            </a:r>
-          </a:p>
-        </p:txBody>
-      </p:sp>
-      <p:sp>
-        <p:nvSpPr>
-          <p:cNvPr id="19" name="Rounded Rectangle 18"/>
+              <a:t>Yes! The black jacket is in stock in size M — EGP 1,250. Would you like me to reserve one?</a:t>
+            </a:r>
+          </a:p>
+        </p:txBody>
+      </p:sp>
+      <p:sp>
+        <p:nvSpPr>
+          <p:cNvPr id="21" name="Rounded Rectangle 20"/>
           <p:cNvSpPr/>
           <p:nvPr/>
         </p:nvSpPr>
@@ -9644,7 +9739,7 @@
       </p:sp>
       <p:sp>
         <p:nvSpPr>
-          <p:cNvPr id="20" name="Rounded Rectangle 19"/>
+          <p:cNvPr id="22" name="Rounded Rectangle 21"/>
           <p:cNvSpPr/>
           <p:nvPr/>
         </p:nvSpPr>
@@ -9692,14 +9787,14 @@
                 </a:solidFill>
                 <a:latin typeface="Open Sans"/>
               </a:rPr>
-              <a:t>Out for delivery today, arriving by 6 PM 📦</a:t>
-            </a:r>
-          </a:p>
-        </p:txBody>
-      </p:sp>
-      <p:sp>
-        <p:nvSpPr>
-          <p:cNvPr id="21" name="Rounded Rectangle 20">
+              <a:t>It’s out for delivery today and should arrive by 6 PM.</a:t>
+            </a:r>
+          </a:p>
+        </p:txBody>
+      </p:sp>
+      <p:sp>
+        <p:nvSpPr>
+          <p:cNvPr id="23" name="Rounded Rectangle 22">
             <a:hlinkClick r:id="rId4" action="ppaction://hlinksldjump"/>
           </p:cNvPr>
           <p:cNvSpPr/>
@@ -9751,14 +9846,14 @@
                 </a:solidFill>
                 <a:latin typeface="JetBrains Mono"/>
               </a:rPr>
-              <a:t>☰  Menu</a:t>
-            </a:r>
-          </a:p>
-        </p:txBody>
-      </p:sp>
-      <p:sp>
-        <p:nvSpPr>
-          <p:cNvPr id="22" name="TextBox 21"/>
+              <a:t>‹  Menu</a:t>
+            </a:r>
+          </a:p>
+        </p:txBody>
+      </p:sp>
+      <p:sp>
+        <p:nvSpPr>
+          <p:cNvPr id="24" name="TextBox 23"/>
           <p:cNvSpPr txBox="1"/>
           <p:nvPr/>
         </p:nvSpPr>
@@ -9936,7 +10031,7 @@
                 </a:solidFill>
                 <a:latin typeface="Open Sans"/>
               </a:rPr>
-              <a:t>Each message routes to the lightest path that solves it — keeping replies instant and costs low.</a:t>
+              <a:t>Every message is handled the right way — keeping replies instant and your customers looked after.</a:t>
             </a:r>
           </a:p>
         </p:txBody>
@@ -10042,13 +10137,13 @@
           <a:p>
             <a:pPr algn="ctr"/>
             <a:r>
-              <a:rPr sz="2400" b="0" i="0">
+              <a:rPr sz="3000" b="1" i="0">
                 <a:solidFill>
                   <a:srgbClr val="FFFFFF"/>
                 </a:solidFill>
-                <a:latin typeface="Open Sans"/>
-              </a:rPr>
-              <a:t>⚡</a:t>
+                <a:latin typeface="Sora"/>
+              </a:rPr>
+              <a:t>1</a:t>
             </a:r>
           </a:p>
         </p:txBody>
@@ -10061,7 +10156,7 @@
         </p:nvSpPr>
         <p:spPr>
           <a:xfrm>
-            <a:off x="1005840" y="3474720"/>
+            <a:off x="1005840" y="3566160"/>
             <a:ext cx="3063240" cy="1463040"/>
           </a:xfrm>
           <a:prstGeom prst="rect">
@@ -10084,13 +10179,13 @@
               </a:spcAft>
             </a:pPr>
             <a:r>
-              <a:rPr sz="1200" b="1" i="0">
-                <a:solidFill>
-                  <a:srgbClr val="7AA8FF"/>
-                </a:solidFill>
-                <a:latin typeface="JetBrains Mono"/>
-              </a:rPr>
-              <a:t>01</a:t>
+              <a:rPr sz="2000" b="1" i="0">
+                <a:solidFill>
+                  <a:srgbClr val="FFFFFF"/>
+                </a:solidFill>
+                <a:latin typeface="Sora"/>
+              </a:rPr>
+              <a:t>Instant answer</a:t>
             </a:r>
           </a:p>
           <a:p>
@@ -10103,32 +10198,13 @@
               </a:spcAft>
             </a:pPr>
             <a:r>
-              <a:rPr sz="2000" b="1" i="0">
-                <a:solidFill>
-                  <a:srgbClr val="FFFFFF"/>
-                </a:solidFill>
-                <a:latin typeface="Sora"/>
-              </a:rPr>
-              <a:t>Instant answer</a:t>
-            </a:r>
-          </a:p>
-          <a:p>
-            <a:pPr algn="l">
-              <a:lnSpc>
-                <a:spcPct val="108000"/>
-              </a:lnSpc>
-              <a:spcAft>
-                <a:spcPts val="400"/>
-              </a:spcAft>
-            </a:pPr>
-            <a:r>
               <a:rPr sz="1200" b="0" i="0">
                 <a:solidFill>
                   <a:srgbClr val="B3C2E0"/>
                 </a:solidFill>
                 <a:latin typeface="Open Sans"/>
               </a:rPr>
-              <a:t>Greetings, thank-yous and duplicate pings are caught by a mechanical pre-filter — zero AI cost.</a:t>
+              <a:t>Greetings, thank-yous and repeat questions are recognised and answered straight away.</a:t>
             </a:r>
           </a:p>
         </p:txBody>
@@ -10189,7 +10265,7 @@
                 </a:solidFill>
                 <a:latin typeface="JetBrains Mono"/>
               </a:rPr>
-              <a:t>“Hey 👋”</a:t>
+              <a:t>“Hi there”</a:t>
             </a:r>
           </a:p>
         </p:txBody>
@@ -10250,7 +10326,7 @@
                 </a:solidFill>
                 <a:latin typeface="JetBrains Mono"/>
               </a:rPr>
-              <a:t>“شكراً 🙏”</a:t>
+              <a:t>“شكراً”</a:t>
             </a:r>
           </a:p>
         </p:txBody>
@@ -10417,13 +10493,13 @@
           <a:p>
             <a:pPr algn="ctr"/>
             <a:r>
-              <a:rPr sz="2400" b="0" i="0">
+              <a:rPr sz="3000" b="1" i="0">
                 <a:solidFill>
                   <a:srgbClr val="FFFFFF"/>
                 </a:solidFill>
-                <a:latin typeface="Open Sans"/>
-              </a:rPr>
-              <a:t>🧠</a:t>
+                <a:latin typeface="Sora"/>
+              </a:rPr>
+              <a:t>2</a:t>
             </a:r>
           </a:p>
         </p:txBody>
@@ -10436,7 +10512,7 @@
         </p:nvSpPr>
         <p:spPr>
           <a:xfrm>
-            <a:off x="4864608" y="3474720"/>
+            <a:off x="4864608" y="3566160"/>
             <a:ext cx="3063240" cy="1463040"/>
           </a:xfrm>
           <a:prstGeom prst="rect">
@@ -10459,13 +10535,13 @@
               </a:spcAft>
             </a:pPr>
             <a:r>
-              <a:rPr sz="1200" b="1" i="0">
-                <a:solidFill>
-                  <a:srgbClr val="7AA8FF"/>
-                </a:solidFill>
-                <a:latin typeface="JetBrains Mono"/>
-              </a:rPr>
-              <a:t>02</a:t>
+              <a:rPr sz="2000" b="1" i="0">
+                <a:solidFill>
+                  <a:srgbClr val="FFFFFF"/>
+                </a:solidFill>
+                <a:latin typeface="Sora"/>
+              </a:rPr>
+              <a:t>Smart reply</a:t>
             </a:r>
           </a:p>
           <a:p>
@@ -10478,32 +10554,13 @@
               </a:spcAft>
             </a:pPr>
             <a:r>
-              <a:rPr sz="2000" b="1" i="0">
-                <a:solidFill>
-                  <a:srgbClr val="FFFFFF"/>
-                </a:solidFill>
-                <a:latin typeface="Sora"/>
-              </a:rPr>
-              <a:t>Smart reply</a:t>
-            </a:r>
-          </a:p>
-          <a:p>
-            <a:pPr algn="l">
-              <a:lnSpc>
-                <a:spcPct val="108000"/>
-              </a:lnSpc>
-              <a:spcAft>
-                <a:spcPts val="400"/>
-              </a:spcAft>
-            </a:pPr>
-            <a:r>
               <a:rPr sz="1200" b="0" i="0">
                 <a:solidFill>
                   <a:srgbClr val="B3C2E0"/>
                 </a:solidFill>
                 <a:latin typeface="Open Sans"/>
               </a:rPr>
-              <a:t>Real product questions trigger an AI search across your live catalog &amp; knowledge base, answered in-language.</a:t>
+              <a:t>Real product questions are answered from your live catalogue, in the customer’s own language.</a:t>
             </a:r>
           </a:p>
         </p:txBody>
@@ -10792,13 +10849,13 @@
           <a:p>
             <a:pPr algn="ctr"/>
             <a:r>
-              <a:rPr sz="2400" b="0" i="0">
+              <a:rPr sz="3000" b="1" i="0">
                 <a:solidFill>
                   <a:srgbClr val="FFFFFF"/>
                 </a:solidFill>
-                <a:latin typeface="Open Sans"/>
-              </a:rPr>
-              <a:t>🤝</a:t>
+                <a:latin typeface="Sora"/>
+              </a:rPr>
+              <a:t>3</a:t>
             </a:r>
           </a:p>
         </p:txBody>
@@ -10811,7 +10868,7 @@
         </p:nvSpPr>
         <p:spPr>
           <a:xfrm>
-            <a:off x="8723376" y="3474720"/>
+            <a:off x="8723376" y="3566160"/>
             <a:ext cx="3063240" cy="1463040"/>
           </a:xfrm>
           <a:prstGeom prst="rect">
@@ -10834,13 +10891,13 @@
               </a:spcAft>
             </a:pPr>
             <a:r>
-              <a:rPr sz="1200" b="1" i="0">
-                <a:solidFill>
-                  <a:srgbClr val="7AA8FF"/>
-                </a:solidFill>
-                <a:latin typeface="JetBrains Mono"/>
-              </a:rPr>
-              <a:t>03</a:t>
+              <a:rPr sz="2000" b="1" i="0">
+                <a:solidFill>
+                  <a:srgbClr val="FFFFFF"/>
+                </a:solidFill>
+                <a:latin typeface="Sora"/>
+              </a:rPr>
+              <a:t>Personal handoff</a:t>
             </a:r>
           </a:p>
           <a:p>
@@ -10853,32 +10910,13 @@
               </a:spcAft>
             </a:pPr>
             <a:r>
-              <a:rPr sz="2000" b="1" i="0">
-                <a:solidFill>
-                  <a:srgbClr val="FFFFFF"/>
-                </a:solidFill>
-                <a:latin typeface="Sora"/>
-              </a:rPr>
-              <a:t>Graceful handoff</a:t>
-            </a:r>
-          </a:p>
-          <a:p>
-            <a:pPr algn="l">
-              <a:lnSpc>
-                <a:spcPct val="108000"/>
-              </a:lnSpc>
-              <a:spcAft>
-                <a:spcPts val="400"/>
-              </a:spcAft>
-            </a:pPr>
-            <a:r>
               <a:rPr sz="1200" b="0" i="0">
                 <a:solidFill>
                   <a:srgbClr val="B3C2E0"/>
                 </a:solidFill>
                 <a:latin typeface="Open Sans"/>
               </a:rPr>
-              <a:t>Low confidence or a complaint? LUMA acknowledges the customer and opens a ticket for your team.</a:t>
+              <a:t>Complaints or anything unusual? LUMA reassures the customer and passes it straight to your team.</a:t>
             </a:r>
           </a:p>
         </p:txBody>
@@ -10939,7 +10977,7 @@
                 </a:solidFill>
                 <a:latin typeface="JetBrains Mono"/>
               </a:rPr>
-              <a:t>“I want a human”</a:t>
+              <a:t>“I’d like to speak to someone”</a:t>
             </a:r>
           </a:p>
         </p:txBody>
@@ -11120,7 +11158,7 @@
                 </a:solidFill>
                 <a:latin typeface="JetBrains Mono"/>
               </a:rPr>
-              <a:t>☰  Menu</a:t>
+              <a:t>‹  Menu</a:t>
             </a:r>
           </a:p>
         </p:txBody>
@@ -11279,7 +11317,7 @@
                 </a:solidFill>
                 <a:latin typeface="Sora"/>
               </a:rPr>
-              <a:t>no code, no new app</a:t>
+              <a:t>no setup headaches</a:t>
             </a:r>
           </a:p>
         </p:txBody>
@@ -11457,7 +11495,7 @@
                 </a:solidFill>
                 <a:latin typeface="Open Sans"/>
               </a:rPr>
-              <a:t>Install from Shopify, link your Instagram Business account. Your catalog syncs automatically.</a:t>
+              <a:t>Link your store and Instagram account in a few clicks. Your products load in automatically.</a:t>
             </a:r>
           </a:p>
         </p:txBody>
@@ -11651,7 +11689,7 @@
                 </a:solidFill>
                 <a:latin typeface="Sora"/>
               </a:rPr>
-              <a:t>Teach</a:t>
+              <a:t>Personalise</a:t>
             </a:r>
           </a:p>
           <a:p>
@@ -11670,7 +11708,7 @@
                 </a:solidFill>
                 <a:latin typeface="Open Sans"/>
               </a:rPr>
-              <a:t>Set your bot’s tone, auto-reply templates, escalation rules, business hours &amp; product facts — once.</a:t>
+              <a:t>Set the tone, your opening hours and a few product details so LUMA sounds just like your brand.</a:t>
             </a:r>
           </a:p>
         </p:txBody>
@@ -11883,7 +11921,7 @@
                 </a:solidFill>
                 <a:latin typeface="Open Sans"/>
               </a:rPr>
-              <a:t>Watch conversations in real time inside Shopify Admin and jump into any thread whenever you want.</a:t>
+              <a:t>Watch conversations as they happen and step into any chat yourself whenever you’d like.</a:t>
             </a:r>
           </a:p>
         </p:txBody>
@@ -11942,7 +11980,7 @@
                 </a:solidFill>
                 <a:latin typeface="JetBrains Mono"/>
               </a:rPr>
-              <a:t>☰  Menu</a:t>
+              <a:t>‹  Menu</a:t>
             </a:r>
           </a:p>
         </p:txBody>
@@ -12151,36 +12189,45 @@
       </p:sp>
       <p:sp>
         <p:nvSpPr>
-          <p:cNvPr id="6" name="TextBox 5"/>
-          <p:cNvSpPr txBox="1"/>
-          <p:nvPr/>
-        </p:nvSpPr>
-        <p:spPr>
-          <a:xfrm>
-            <a:off x="987552" y="1965960"/>
-            <a:ext cx="914400" cy="548640"/>
-          </a:xfrm>
-          <a:prstGeom prst="rect">
-            <a:avLst/>
-          </a:prstGeom>
-          <a:noFill/>
-        </p:spPr>
-        <p:txBody>
-          <a:bodyPr wrap="square" anchor="t" lIns="0" rIns="0" tIns="0" bIns="0">
-            <a:spAutoFit/>
-          </a:bodyPr>
-          <a:lstStyle/>
-          <a:p>
-            <a:pPr algn="l"/>
-            <a:r>
-              <a:rPr sz="2400" b="0" i="0">
-                <a:solidFill>
-                  <a:srgbClr val="7AA8FF"/>
-                </a:solidFill>
-                <a:latin typeface="Open Sans"/>
-              </a:rPr>
-              <a:t>📥</a:t>
-            </a:r>
+          <p:cNvPr id="6" name="Oval 5"/>
+          <p:cNvSpPr/>
+          <p:nvPr/>
+        </p:nvSpPr>
+        <p:spPr>
+          <a:xfrm>
+            <a:off x="1005840" y="2075688"/>
+            <a:ext cx="146304" cy="146304"/>
+          </a:xfrm>
+          <a:prstGeom prst="ellipse">
+            <a:avLst/>
+          </a:prstGeom>
+          <a:solidFill>
+            <a:srgbClr val="7AA8FF"/>
+          </a:solidFill>
+          <a:ln>
+            <a:noFill/>
+          </a:ln>
+          <a:effectLst/>
+        </p:spPr>
+        <p:style>
+          <a:lnRef idx="1">
+            <a:schemeClr val="accent1"/>
+          </a:lnRef>
+          <a:fillRef idx="3">
+            <a:schemeClr val="accent1"/>
+          </a:fillRef>
+          <a:effectRef idx="2">
+            <a:schemeClr val="accent1"/>
+          </a:effectRef>
+          <a:fontRef idx="minor">
+            <a:schemeClr val="lt1"/>
+          </a:fontRef>
+        </p:style>
+        <p:txBody>
+          <a:bodyPr rtlCol="0" anchor="ctr"/>
+          <a:lstStyle/>
+          <a:p>
+            <a:pPr algn="ctr"/>
           </a:p>
         </p:txBody>
       </p:sp>
@@ -12192,7 +12239,7 @@
         </p:nvSpPr>
         <p:spPr>
           <a:xfrm>
-            <a:off x="987552" y="2441448"/>
+            <a:off x="987552" y="2386584"/>
             <a:ext cx="3008376" cy="731520"/>
           </a:xfrm>
           <a:prstGeom prst="rect">
@@ -12221,7 +12268,7 @@
                 </a:solidFill>
                 <a:latin typeface="Sora"/>
               </a:rPr>
-              <a:t>Unified inbox</a:t>
+              <a:t>One inbox</a:t>
             </a:r>
           </a:p>
           <a:p>
@@ -12240,7 +12287,7 @@
                 </a:solidFill>
                 <a:latin typeface="Open Sans"/>
               </a:rPr>
-              <a:t>Instagram DMs + Shopify chat in one queue</a:t>
+              <a:t>Instagram and website chats together in one place</a:t>
             </a:r>
           </a:p>
         </p:txBody>
@@ -12299,36 +12346,45 @@
       </p:sp>
       <p:sp>
         <p:nvSpPr>
-          <p:cNvPr id="9" name="TextBox 8"/>
-          <p:cNvSpPr txBox="1"/>
-          <p:nvPr/>
-        </p:nvSpPr>
-        <p:spPr>
-          <a:xfrm>
-            <a:off x="4800600" y="1965960"/>
-            <a:ext cx="914400" cy="548640"/>
-          </a:xfrm>
-          <a:prstGeom prst="rect">
-            <a:avLst/>
-          </a:prstGeom>
-          <a:noFill/>
-        </p:spPr>
-        <p:txBody>
-          <a:bodyPr wrap="square" anchor="t" lIns="0" rIns="0" tIns="0" bIns="0">
-            <a:spAutoFit/>
-          </a:bodyPr>
-          <a:lstStyle/>
-          <a:p>
-            <a:pPr algn="l"/>
-            <a:r>
-              <a:rPr sz="2400" b="0" i="0">
-                <a:solidFill>
-                  <a:srgbClr val="7AA8FF"/>
-                </a:solidFill>
-                <a:latin typeface="Open Sans"/>
-              </a:rPr>
-              <a:t>🌐</a:t>
-            </a:r>
+          <p:cNvPr id="9" name="Oval 8"/>
+          <p:cNvSpPr/>
+          <p:nvPr/>
+        </p:nvSpPr>
+        <p:spPr>
+          <a:xfrm>
+            <a:off x="4818888" y="2075688"/>
+            <a:ext cx="146304" cy="146304"/>
+          </a:xfrm>
+          <a:prstGeom prst="ellipse">
+            <a:avLst/>
+          </a:prstGeom>
+          <a:solidFill>
+            <a:srgbClr val="7AA8FF"/>
+          </a:solidFill>
+          <a:ln>
+            <a:noFill/>
+          </a:ln>
+          <a:effectLst/>
+        </p:spPr>
+        <p:style>
+          <a:lnRef idx="1">
+            <a:schemeClr val="accent1"/>
+          </a:lnRef>
+          <a:fillRef idx="3">
+            <a:schemeClr val="accent1"/>
+          </a:fillRef>
+          <a:effectRef idx="2">
+            <a:schemeClr val="accent1"/>
+          </a:effectRef>
+          <a:fontRef idx="minor">
+            <a:schemeClr val="lt1"/>
+          </a:fontRef>
+        </p:style>
+        <p:txBody>
+          <a:bodyPr rtlCol="0" anchor="ctr"/>
+          <a:lstStyle/>
+          <a:p>
+            <a:pPr algn="ctr"/>
           </a:p>
         </p:txBody>
       </p:sp>
@@ -12340,7 +12396,7 @@
         </p:nvSpPr>
         <p:spPr>
           <a:xfrm>
-            <a:off x="4800600" y="2441448"/>
+            <a:off x="4800600" y="2386584"/>
             <a:ext cx="3008376" cy="731520"/>
           </a:xfrm>
           <a:prstGeom prst="rect">
@@ -12369,7 +12425,7 @@
                 </a:solidFill>
                 <a:latin typeface="Sora"/>
               </a:rPr>
-              <a:t>Native trilingual</a:t>
+              <a:t>Three languages</a:t>
             </a:r>
           </a:p>
           <a:p>
@@ -12388,7 +12444,7 @@
                 </a:solidFill>
                 <a:latin typeface="Open Sans"/>
               </a:rPr>
-              <a:t>Arabic, English &amp; Franco-Arabic per message</a:t>
+              <a:t>Speaks Arabic, English and Franco-Arabic</a:t>
             </a:r>
           </a:p>
         </p:txBody>
@@ -12447,36 +12503,45 @@
       </p:sp>
       <p:sp>
         <p:nvSpPr>
-          <p:cNvPr id="12" name="TextBox 11"/>
-          <p:cNvSpPr txBox="1"/>
-          <p:nvPr/>
-        </p:nvSpPr>
-        <p:spPr>
-          <a:xfrm>
-            <a:off x="8613648" y="1965960"/>
-            <a:ext cx="914400" cy="548640"/>
-          </a:xfrm>
-          <a:prstGeom prst="rect">
-            <a:avLst/>
-          </a:prstGeom>
-          <a:noFill/>
-        </p:spPr>
-        <p:txBody>
-          <a:bodyPr wrap="square" anchor="t" lIns="0" rIns="0" tIns="0" bIns="0">
-            <a:spAutoFit/>
-          </a:bodyPr>
-          <a:lstStyle/>
-          <a:p>
-            <a:pPr algn="l"/>
-            <a:r>
-              <a:rPr sz="2400" b="0" i="0">
-                <a:solidFill>
-                  <a:srgbClr val="7AA8FF"/>
-                </a:solidFill>
-                <a:latin typeface="Open Sans"/>
-              </a:rPr>
-              <a:t>📦</a:t>
-            </a:r>
+          <p:cNvPr id="12" name="Oval 11"/>
+          <p:cNvSpPr/>
+          <p:nvPr/>
+        </p:nvSpPr>
+        <p:spPr>
+          <a:xfrm>
+            <a:off x="8631936" y="2075688"/>
+            <a:ext cx="146304" cy="146304"/>
+          </a:xfrm>
+          <a:prstGeom prst="ellipse">
+            <a:avLst/>
+          </a:prstGeom>
+          <a:solidFill>
+            <a:srgbClr val="7AA8FF"/>
+          </a:solidFill>
+          <a:ln>
+            <a:noFill/>
+          </a:ln>
+          <a:effectLst/>
+        </p:spPr>
+        <p:style>
+          <a:lnRef idx="1">
+            <a:schemeClr val="accent1"/>
+          </a:lnRef>
+          <a:fillRef idx="3">
+            <a:schemeClr val="accent1"/>
+          </a:fillRef>
+          <a:effectRef idx="2">
+            <a:schemeClr val="accent1"/>
+          </a:effectRef>
+          <a:fontRef idx="minor">
+            <a:schemeClr val="lt1"/>
+          </a:fontRef>
+        </p:style>
+        <p:txBody>
+          <a:bodyPr rtlCol="0" anchor="ctr"/>
+          <a:lstStyle/>
+          <a:p>
+            <a:pPr algn="ctr"/>
           </a:p>
         </p:txBody>
       </p:sp>
@@ -12488,7 +12553,7 @@
         </p:nvSpPr>
         <p:spPr>
           <a:xfrm>
-            <a:off x="8613648" y="2441448"/>
+            <a:off x="8613648" y="2386584"/>
             <a:ext cx="3008376" cy="731520"/>
           </a:xfrm>
           <a:prstGeom prst="rect">
@@ -12517,7 +12582,7 @@
                 </a:solidFill>
                 <a:latin typeface="Sora"/>
               </a:rPr>
-              <a:t>Live order tracking</a:t>
+              <a:t>Order tracking</a:t>
             </a:r>
           </a:p>
           <a:p>
@@ -12536,7 +12601,7 @@
                 </a:solidFill>
                 <a:latin typeface="Open Sans"/>
               </a:rPr>
-              <a:t>Real Shopify order data, zero hallucination</a:t>
+              <a:t>Tells customers exactly where their order is</a:t>
             </a:r>
           </a:p>
         </p:txBody>
@@ -12595,36 +12660,45 @@
       </p:sp>
       <p:sp>
         <p:nvSpPr>
-          <p:cNvPr id="15" name="TextBox 14"/>
-          <p:cNvSpPr txBox="1"/>
-          <p:nvPr/>
-        </p:nvSpPr>
-        <p:spPr>
-          <a:xfrm>
-            <a:off x="987552" y="3657600"/>
-            <a:ext cx="914400" cy="548640"/>
-          </a:xfrm>
-          <a:prstGeom prst="rect">
-            <a:avLst/>
-          </a:prstGeom>
-          <a:noFill/>
-        </p:spPr>
-        <p:txBody>
-          <a:bodyPr wrap="square" anchor="t" lIns="0" rIns="0" tIns="0" bIns="0">
-            <a:spAutoFit/>
-          </a:bodyPr>
-          <a:lstStyle/>
-          <a:p>
-            <a:pPr algn="l"/>
-            <a:r>
-              <a:rPr sz="2400" b="0" i="0">
-                <a:solidFill>
-                  <a:srgbClr val="7AA8FF"/>
-                </a:solidFill>
-                <a:latin typeface="Open Sans"/>
-              </a:rPr>
-              <a:t>⚡</a:t>
-            </a:r>
+          <p:cNvPr id="15" name="Oval 14"/>
+          <p:cNvSpPr/>
+          <p:nvPr/>
+        </p:nvSpPr>
+        <p:spPr>
+          <a:xfrm>
+            <a:off x="1005840" y="3767328"/>
+            <a:ext cx="146304" cy="146304"/>
+          </a:xfrm>
+          <a:prstGeom prst="ellipse">
+            <a:avLst/>
+          </a:prstGeom>
+          <a:solidFill>
+            <a:srgbClr val="7AA8FF"/>
+          </a:solidFill>
+          <a:ln>
+            <a:noFill/>
+          </a:ln>
+          <a:effectLst/>
+        </p:spPr>
+        <p:style>
+          <a:lnRef idx="1">
+            <a:schemeClr val="accent1"/>
+          </a:lnRef>
+          <a:fillRef idx="3">
+            <a:schemeClr val="accent1"/>
+          </a:fillRef>
+          <a:effectRef idx="2">
+            <a:schemeClr val="accent1"/>
+          </a:effectRef>
+          <a:fontRef idx="minor">
+            <a:schemeClr val="lt1"/>
+          </a:fontRef>
+        </p:style>
+        <p:txBody>
+          <a:bodyPr rtlCol="0" anchor="ctr"/>
+          <a:lstStyle/>
+          <a:p>
+            <a:pPr algn="ctr"/>
           </a:p>
         </p:txBody>
       </p:sp>
@@ -12636,7 +12710,7 @@
         </p:nvSpPr>
         <p:spPr>
           <a:xfrm>
-            <a:off x="987552" y="4133088"/>
+            <a:off x="987552" y="4078224"/>
             <a:ext cx="3008376" cy="731520"/>
           </a:xfrm>
           <a:prstGeom prst="rect">
@@ -12665,7 +12739,7 @@
                 </a:solidFill>
                 <a:latin typeface="Sora"/>
               </a:rPr>
-              <a:t>Smart pre-filter</a:t>
+              <a:t>Instant answers</a:t>
             </a:r>
           </a:p>
           <a:p>
@@ -12684,7 +12758,7 @@
                 </a:solidFill>
                 <a:latin typeface="Open Sans"/>
               </a:rPr>
-              <a:t>Mechanical checks before any AI is called</a:t>
+              <a:t>Common questions answered in a moment</a:t>
             </a:r>
           </a:p>
         </p:txBody>
@@ -12743,36 +12817,45 @@
       </p:sp>
       <p:sp>
         <p:nvSpPr>
-          <p:cNvPr id="18" name="TextBox 17"/>
-          <p:cNvSpPr txBox="1"/>
-          <p:nvPr/>
-        </p:nvSpPr>
-        <p:spPr>
-          <a:xfrm>
-            <a:off x="4800600" y="3657600"/>
-            <a:ext cx="914400" cy="548640"/>
-          </a:xfrm>
-          <a:prstGeom prst="rect">
-            <a:avLst/>
-          </a:prstGeom>
-          <a:noFill/>
-        </p:spPr>
-        <p:txBody>
-          <a:bodyPr wrap="square" anchor="t" lIns="0" rIns="0" tIns="0" bIns="0">
-            <a:spAutoFit/>
-          </a:bodyPr>
-          <a:lstStyle/>
-          <a:p>
-            <a:pPr algn="l"/>
-            <a:r>
-              <a:rPr sz="2400" b="0" i="0">
-                <a:solidFill>
-                  <a:srgbClr val="7AA8FF"/>
-                </a:solidFill>
-                <a:latin typeface="Open Sans"/>
-              </a:rPr>
-              <a:t>🎯</a:t>
-            </a:r>
+          <p:cNvPr id="18" name="Oval 17"/>
+          <p:cNvSpPr/>
+          <p:nvPr/>
+        </p:nvSpPr>
+        <p:spPr>
+          <a:xfrm>
+            <a:off x="4818888" y="3767328"/>
+            <a:ext cx="146304" cy="146304"/>
+          </a:xfrm>
+          <a:prstGeom prst="ellipse">
+            <a:avLst/>
+          </a:prstGeom>
+          <a:solidFill>
+            <a:srgbClr val="7AA8FF"/>
+          </a:solidFill>
+          <a:ln>
+            <a:noFill/>
+          </a:ln>
+          <a:effectLst/>
+        </p:spPr>
+        <p:style>
+          <a:lnRef idx="1">
+            <a:schemeClr val="accent1"/>
+          </a:lnRef>
+          <a:fillRef idx="3">
+            <a:schemeClr val="accent1"/>
+          </a:fillRef>
+          <a:effectRef idx="2">
+            <a:schemeClr val="accent1"/>
+          </a:effectRef>
+          <a:fontRef idx="minor">
+            <a:schemeClr val="lt1"/>
+          </a:fontRef>
+        </p:style>
+        <p:txBody>
+          <a:bodyPr rtlCol="0" anchor="ctr"/>
+          <a:lstStyle/>
+          <a:p>
+            <a:pPr algn="ctr"/>
           </a:p>
         </p:txBody>
       </p:sp>
@@ -12784,7 +12867,7 @@
         </p:nvSpPr>
         <p:spPr>
           <a:xfrm>
-            <a:off x="4800600" y="4133088"/>
+            <a:off x="4800600" y="4078224"/>
             <a:ext cx="3008376" cy="731520"/>
           </a:xfrm>
           <a:prstGeom prst="rect">
@@ -12813,7 +12896,7 @@
                 </a:solidFill>
                 <a:latin typeface="Sora"/>
               </a:rPr>
-              <a:t>Confidence scoring</a:t>
+              <a:t>Smart handoff</a:t>
             </a:r>
           </a:p>
           <a:p>
@@ -12832,7 +12915,7 @@
                 </a:solidFill>
                 <a:latin typeface="Open Sans"/>
               </a:rPr>
-              <a:t>Auto-escalates on low confidence or negativity</a:t>
+              <a:t>Knows when to bring in your team</a:t>
             </a:r>
           </a:p>
         </p:txBody>
@@ -12891,36 +12974,45 @@
       </p:sp>
       <p:sp>
         <p:nvSpPr>
-          <p:cNvPr id="21" name="TextBox 20"/>
-          <p:cNvSpPr txBox="1"/>
-          <p:nvPr/>
-        </p:nvSpPr>
-        <p:spPr>
-          <a:xfrm>
-            <a:off x="8613648" y="3657600"/>
-            <a:ext cx="914400" cy="548640"/>
-          </a:xfrm>
-          <a:prstGeom prst="rect">
-            <a:avLst/>
-          </a:prstGeom>
-          <a:noFill/>
-        </p:spPr>
-        <p:txBody>
-          <a:bodyPr wrap="square" anchor="t" lIns="0" rIns="0" tIns="0" bIns="0">
-            <a:spAutoFit/>
-          </a:bodyPr>
-          <a:lstStyle/>
-          <a:p>
-            <a:pPr algn="l"/>
-            <a:r>
-              <a:rPr sz="2400" b="0" i="0">
-                <a:solidFill>
-                  <a:srgbClr val="7AA8FF"/>
-                </a:solidFill>
-                <a:latin typeface="Open Sans"/>
-              </a:rPr>
-              <a:t>📊</a:t>
-            </a:r>
+          <p:cNvPr id="21" name="Oval 20"/>
+          <p:cNvSpPr/>
+          <p:nvPr/>
+        </p:nvSpPr>
+        <p:spPr>
+          <a:xfrm>
+            <a:off x="8631936" y="3767328"/>
+            <a:ext cx="146304" cy="146304"/>
+          </a:xfrm>
+          <a:prstGeom prst="ellipse">
+            <a:avLst/>
+          </a:prstGeom>
+          <a:solidFill>
+            <a:srgbClr val="7AA8FF"/>
+          </a:solidFill>
+          <a:ln>
+            <a:noFill/>
+          </a:ln>
+          <a:effectLst/>
+        </p:spPr>
+        <p:style>
+          <a:lnRef idx="1">
+            <a:schemeClr val="accent1"/>
+          </a:lnRef>
+          <a:fillRef idx="3">
+            <a:schemeClr val="accent1"/>
+          </a:fillRef>
+          <a:effectRef idx="2">
+            <a:schemeClr val="accent1"/>
+          </a:effectRef>
+          <a:fontRef idx="minor">
+            <a:schemeClr val="lt1"/>
+          </a:fontRef>
+        </p:style>
+        <p:txBody>
+          <a:bodyPr rtlCol="0" anchor="ctr"/>
+          <a:lstStyle/>
+          <a:p>
+            <a:pPr algn="ctr"/>
           </a:p>
         </p:txBody>
       </p:sp>
@@ -12932,7 +13024,7 @@
         </p:nvSpPr>
         <p:spPr>
           <a:xfrm>
-            <a:off x="8613648" y="4133088"/>
+            <a:off x="8613648" y="4078224"/>
             <a:ext cx="3008376" cy="731520"/>
           </a:xfrm>
           <a:prstGeom prst="rect">
@@ -12961,7 +13053,7 @@
                 </a:solidFill>
                 <a:latin typeface="Sora"/>
               </a:rPr>
-              <a:t>Analytics dashboard</a:t>
+              <a:t>Simple dashboard</a:t>
             </a:r>
           </a:p>
           <a:p>
@@ -12980,7 +13072,7 @@
                 </a:solidFill>
                 <a:latin typeface="Open Sans"/>
               </a:rPr>
-              <a:t>Volume, resolution rate, peak-hour heatmap</a:t>
+              <a:t>See your busiest hours and top questions</a:t>
             </a:r>
           </a:p>
         </p:txBody>
@@ -13039,36 +13131,45 @@
       </p:sp>
       <p:sp>
         <p:nvSpPr>
-          <p:cNvPr id="24" name="TextBox 23"/>
-          <p:cNvSpPr txBox="1"/>
-          <p:nvPr/>
-        </p:nvSpPr>
-        <p:spPr>
-          <a:xfrm>
-            <a:off x="987552" y="5349240"/>
-            <a:ext cx="914400" cy="548640"/>
-          </a:xfrm>
-          <a:prstGeom prst="rect">
-            <a:avLst/>
-          </a:prstGeom>
-          <a:noFill/>
-        </p:spPr>
-        <p:txBody>
-          <a:bodyPr wrap="square" anchor="t" lIns="0" rIns="0" tIns="0" bIns="0">
-            <a:spAutoFit/>
-          </a:bodyPr>
-          <a:lstStyle/>
-          <a:p>
-            <a:pPr algn="l"/>
-            <a:r>
-              <a:rPr sz="2400" b="0" i="0">
-                <a:solidFill>
-                  <a:srgbClr val="7AA8FF"/>
-                </a:solidFill>
-                <a:latin typeface="Open Sans"/>
-              </a:rPr>
-              <a:t>📚</a:t>
-            </a:r>
+          <p:cNvPr id="24" name="Oval 23"/>
+          <p:cNvSpPr/>
+          <p:nvPr/>
+        </p:nvSpPr>
+        <p:spPr>
+          <a:xfrm>
+            <a:off x="1005840" y="5458968"/>
+            <a:ext cx="146304" cy="146304"/>
+          </a:xfrm>
+          <a:prstGeom prst="ellipse">
+            <a:avLst/>
+          </a:prstGeom>
+          <a:solidFill>
+            <a:srgbClr val="7AA8FF"/>
+          </a:solidFill>
+          <a:ln>
+            <a:noFill/>
+          </a:ln>
+          <a:effectLst/>
+        </p:spPr>
+        <p:style>
+          <a:lnRef idx="1">
+            <a:schemeClr val="accent1"/>
+          </a:lnRef>
+          <a:fillRef idx="3">
+            <a:schemeClr val="accent1"/>
+          </a:fillRef>
+          <a:effectRef idx="2">
+            <a:schemeClr val="accent1"/>
+          </a:effectRef>
+          <a:fontRef idx="minor">
+            <a:schemeClr val="lt1"/>
+          </a:fontRef>
+        </p:style>
+        <p:txBody>
+          <a:bodyPr rtlCol="0" anchor="ctr"/>
+          <a:lstStyle/>
+          <a:p>
+            <a:pPr algn="ctr"/>
           </a:p>
         </p:txBody>
       </p:sp>
@@ -13080,7 +13181,7 @@
         </p:nvSpPr>
         <p:spPr>
           <a:xfrm>
-            <a:off x="987552" y="5824728"/>
+            <a:off x="987552" y="5769864"/>
             <a:ext cx="3008376" cy="731520"/>
           </a:xfrm>
           <a:prstGeom prst="rect">
@@ -13128,7 +13229,7 @@
                 </a:solidFill>
                 <a:latin typeface="Open Sans"/>
               </a:rPr>
-              <a:t>Attach facts to products; bot cites verbatim</a:t>
+              <a:t>Shares accurate details about your products</a:t>
             </a:r>
           </a:p>
         </p:txBody>
@@ -13187,36 +13288,45 @@
       </p:sp>
       <p:sp>
         <p:nvSpPr>
-          <p:cNvPr id="27" name="TextBox 26"/>
-          <p:cNvSpPr txBox="1"/>
-          <p:nvPr/>
-        </p:nvSpPr>
-        <p:spPr>
-          <a:xfrm>
-            <a:off x="4800600" y="5349240"/>
-            <a:ext cx="914400" cy="548640"/>
-          </a:xfrm>
-          <a:prstGeom prst="rect">
-            <a:avLst/>
-          </a:prstGeom>
-          <a:noFill/>
-        </p:spPr>
-        <p:txBody>
-          <a:bodyPr wrap="square" anchor="t" lIns="0" rIns="0" tIns="0" bIns="0">
-            <a:spAutoFit/>
-          </a:bodyPr>
-          <a:lstStyle/>
-          <a:p>
-            <a:pPr algn="l"/>
-            <a:r>
-              <a:rPr sz="2400" b="0" i="0">
-                <a:solidFill>
-                  <a:srgbClr val="7AA8FF"/>
-                </a:solidFill>
-                <a:latin typeface="Open Sans"/>
-              </a:rPr>
-              <a:t>🌙</a:t>
-            </a:r>
+          <p:cNvPr id="27" name="Oval 26"/>
+          <p:cNvSpPr/>
+          <p:nvPr/>
+        </p:nvSpPr>
+        <p:spPr>
+          <a:xfrm>
+            <a:off x="4818888" y="5458968"/>
+            <a:ext cx="146304" cy="146304"/>
+          </a:xfrm>
+          <a:prstGeom prst="ellipse">
+            <a:avLst/>
+          </a:prstGeom>
+          <a:solidFill>
+            <a:srgbClr val="7AA8FF"/>
+          </a:solidFill>
+          <a:ln>
+            <a:noFill/>
+          </a:ln>
+          <a:effectLst/>
+        </p:spPr>
+        <p:style>
+          <a:lnRef idx="1">
+            <a:schemeClr val="accent1"/>
+          </a:lnRef>
+          <a:fillRef idx="3">
+            <a:schemeClr val="accent1"/>
+          </a:fillRef>
+          <a:effectRef idx="2">
+            <a:schemeClr val="accent1"/>
+          </a:effectRef>
+          <a:fontRef idx="minor">
+            <a:schemeClr val="lt1"/>
+          </a:fontRef>
+        </p:style>
+        <p:txBody>
+          <a:bodyPr rtlCol="0" anchor="ctr"/>
+          <a:lstStyle/>
+          <a:p>
+            <a:pPr algn="ctr"/>
           </a:p>
         </p:txBody>
       </p:sp>
@@ -13228,7 +13338,7 @@
         </p:nvSpPr>
         <p:spPr>
           <a:xfrm>
-            <a:off x="4800600" y="5824728"/>
+            <a:off x="4800600" y="5769864"/>
             <a:ext cx="3008376" cy="731520"/>
           </a:xfrm>
           <a:prstGeom prst="rect">
@@ -13276,7 +13386,7 @@
                 </a:solidFill>
                 <a:latin typeface="Open Sans"/>
               </a:rPr>
-              <a:t>Context-aware off-hours messages, not templates</a:t>
+              <a:t>Keeps answering when you’re closed</a:t>
             </a:r>
           </a:p>
         </p:txBody>
@@ -13335,36 +13445,45 @@
       </p:sp>
       <p:sp>
         <p:nvSpPr>
-          <p:cNvPr id="30" name="TextBox 29"/>
-          <p:cNvSpPr txBox="1"/>
-          <p:nvPr/>
-        </p:nvSpPr>
-        <p:spPr>
-          <a:xfrm>
-            <a:off x="8613648" y="5349240"/>
-            <a:ext cx="914400" cy="548640"/>
-          </a:xfrm>
-          <a:prstGeom prst="rect">
-            <a:avLst/>
-          </a:prstGeom>
-          <a:noFill/>
-        </p:spPr>
-        <p:txBody>
-          <a:bodyPr wrap="square" anchor="t" lIns="0" rIns="0" tIns="0" bIns="0">
-            <a:spAutoFit/>
-          </a:bodyPr>
-          <a:lstStyle/>
-          <a:p>
-            <a:pPr algn="l"/>
-            <a:r>
-              <a:rPr sz="2400" b="0" i="0">
-                <a:solidFill>
-                  <a:srgbClr val="7AA8FF"/>
-                </a:solidFill>
-                <a:latin typeface="Open Sans"/>
-              </a:rPr>
-              <a:t>👍</a:t>
-            </a:r>
+          <p:cNvPr id="30" name="Oval 29"/>
+          <p:cNvSpPr/>
+          <p:nvPr/>
+        </p:nvSpPr>
+        <p:spPr>
+          <a:xfrm>
+            <a:off x="8631936" y="5458968"/>
+            <a:ext cx="146304" cy="146304"/>
+          </a:xfrm>
+          <a:prstGeom prst="ellipse">
+            <a:avLst/>
+          </a:prstGeom>
+          <a:solidFill>
+            <a:srgbClr val="7AA8FF"/>
+          </a:solidFill>
+          <a:ln>
+            <a:noFill/>
+          </a:ln>
+          <a:effectLst/>
+        </p:spPr>
+        <p:style>
+          <a:lnRef idx="1">
+            <a:schemeClr val="accent1"/>
+          </a:lnRef>
+          <a:fillRef idx="3">
+            <a:schemeClr val="accent1"/>
+          </a:fillRef>
+          <a:effectRef idx="2">
+            <a:schemeClr val="accent1"/>
+          </a:effectRef>
+          <a:fontRef idx="minor">
+            <a:schemeClr val="lt1"/>
+          </a:fontRef>
+        </p:style>
+        <p:txBody>
+          <a:bodyPr rtlCol="0" anchor="ctr"/>
+          <a:lstStyle/>
+          <a:p>
+            <a:pPr algn="ctr"/>
           </a:p>
         </p:txBody>
       </p:sp>
@@ -13376,7 +13495,7 @@
         </p:nvSpPr>
         <p:spPr>
           <a:xfrm>
-            <a:off x="8613648" y="5824728"/>
+            <a:off x="8613648" y="5769864"/>
             <a:ext cx="3008376" cy="731520"/>
           </a:xfrm>
           <a:prstGeom prst="rect">
@@ -13405,7 +13524,7 @@
                 </a:solidFill>
                 <a:latin typeface="Sora"/>
               </a:rPr>
-              <a:t>Feedback loop</a:t>
+              <a:t>Customer feedback</a:t>
             </a:r>
           </a:p>
           <a:p>
@@ -13424,7 +13543,7 @@
                 </a:solidFill>
                 <a:latin typeface="Open Sans"/>
               </a:rPr>
-              <a:t>“Was this helpful?” tunes future replies</a:t>
+              <a:t>Asks each customer if the answer helped</a:t>
             </a:r>
           </a:p>
         </p:txBody>
@@ -13483,7 +13602,7 @@
                 </a:solidFill>
                 <a:latin typeface="JetBrains Mono"/>
               </a:rPr>
-              <a:t>☰  Menu</a:t>
+              <a:t>‹  Menu</a:t>
             </a:r>
           </a:p>
         </p:txBody>
@@ -13927,7 +14046,7 @@
                 </a:solidFill>
                 <a:latin typeface="Open Sans"/>
               </a:rPr>
-              <a:t>Speaks Arabic &amp; Franco natively</a:t>
+              <a:t>Speaks Arabic and Franco-Arabic naturally</a:t>
             </a:r>
           </a:p>
         </p:txBody>
@@ -14067,7 +14186,7 @@
                 </a:solidFill>
                 <a:latin typeface="Open Sans"/>
               </a:rPr>
-              <a:t>Reads real Shopify order data</a:t>
+              <a:t>Gives accurate, up-to-date order updates</a:t>
             </a:r>
           </a:p>
         </p:txBody>
@@ -14137,7 +14256,7 @@
                 </a:solidFill>
                 <a:latin typeface="Open Sans"/>
               </a:rPr>
-              <a:t>Yet another dashboard to open</a:t>
+              <a:t>Yet another app to open</a:t>
             </a:r>
           </a:p>
         </p:txBody>
@@ -14207,7 +14326,7 @@
                 </a:solidFill>
                 <a:latin typeface="Open Sans"/>
               </a:rPr>
-              <a:t>Embedded in your Shopify Admin</a:t>
+              <a:t>Works right inside your store</a:t>
             </a:r>
           </a:p>
         </p:txBody>
@@ -14277,7 +14396,7 @@
                 </a:solidFill>
                 <a:latin typeface="Open Sans"/>
               </a:rPr>
-              <a:t>Burns tokens on “hi”</a:t>
+              <a:t>Replies sound robotic</a:t>
             </a:r>
           </a:p>
         </p:txBody>
@@ -14347,7 +14466,7 @@
                 </a:solidFill>
                 <a:latin typeface="Open Sans"/>
               </a:rPr>
-              <a:t>Pre-filters trivial messages free</a:t>
+              <a:t>Sounds like your brand</a:t>
             </a:r>
           </a:p>
         </p:txBody>
@@ -14417,7 +14536,7 @@
                 </a:solidFill>
                 <a:latin typeface="Open Sans"/>
               </a:rPr>
-              <a:t>Loops when confused</a:t>
+              <a:t>Gets stuck when confused</a:t>
             </a:r>
           </a:p>
         </p:txBody>
@@ -14487,7 +14606,7 @@
                 </a:solidFill>
                 <a:latin typeface="Open Sans"/>
               </a:rPr>
-              <a:t>Escalates to a human gracefully</a:t>
+              <a:t>Hands off to your team smoothly</a:t>
             </a:r>
           </a:p>
         </p:txBody>
@@ -14546,7 +14665,7 @@
                 </a:solidFill>
                 <a:latin typeface="JetBrains Mono"/>
               </a:rPr>
-              <a:t>☰  Menu</a:t>
+              <a:t>‹  Menu</a:t>
             </a:r>
           </a:p>
         </p:txBody>
@@ -14799,7 +14918,7 @@
                 </a:solidFill>
                 <a:latin typeface="Sora"/>
               </a:rPr>
-              <a:t>&lt; 2s</a:t>
+              <a:t>Seconds</a:t>
             </a:r>
           </a:p>
         </p:txBody>
@@ -14860,7 +14979,7 @@
                 </a:solidFill>
                 <a:latin typeface="Open Sans"/>
               </a:rPr>
-              <a:t>From customer message to a visible answer.</a:t>
+              <a:t>Customers get an answer almost the moment they ask.</a:t>
             </a:r>
           </a:p>
         </p:txBody>
@@ -15015,7 +15134,7 @@
                 </a:solidFill>
                 <a:latin typeface="Open Sans"/>
               </a:rPr>
-              <a:t>Arabic, English &amp; Franco-Arabic, auto-detected.</a:t>
+              <a:t>Arabic, English and Franco-Arabic, understood automatically.</a:t>
             </a:r>
           </a:p>
         </p:txBody>
@@ -15170,7 +15289,7 @@
                 </a:solidFill>
                 <a:latin typeface="Open Sans"/>
               </a:rPr>
-              <a:t>Never sleeps — customers always hear back.</a:t>
+              <a:t>Never sleeps — your customers always hear back.</a:t>
             </a:r>
           </a:p>
         </p:txBody>
@@ -15264,7 +15383,7 @@
                 </a:solidFill>
                 <a:latin typeface="Sora"/>
               </a:rPr>
-              <a:t>2+1</a:t>
+              <a:t>3</a:t>
             </a:r>
           </a:p>
         </p:txBody>
@@ -15325,7 +15444,7 @@
                 </a:solidFill>
                 <a:latin typeface="Open Sans"/>
               </a:rPr>
-              <a:t>Instagram + Shopify chat. WhatsApp coming soon.</a:t>
+              <a:t>Instagram and website chat today, WhatsApp soon.</a:t>
             </a:r>
           </a:p>
         </p:txBody>
@@ -15384,7 +15503,7 @@
                 </a:solidFill>
                 <a:latin typeface="JetBrains Mono"/>
               </a:rPr>
-              <a:t>☰  Menu</a:t>
+              <a:t>‹  Menu</a:t>
             </a:r>
           </a:p>
         </p:txBody>

</xml_diff>